<commit_message>
Ajoute un filigrane de copyright sur les supports telechargeables
- PowerPoint (.pptx) : zone de texte en bas de chaque diapo
- PDF : filigrane integre sur chaque page
- Mention : (c) titi_23 - mediateur-numerique.github.io - Reproduction
  interdite sans autorisation

26 fichiers traites avec succes (toutes les presentations PowerPoint et
tous les PDF). Les 10 fichiers Word (.docx) ne sont pas filigranes dans
ce commit - l'export PDF de Word s'est revele instable dans cet
environnement (echecs intermittents non reproductibles malgre plusieurs
approches). A traiter separement.

Co-Authored-By: Claude Sonnet 5 <noreply@anthropic.com>
</commit_message>
<xml_diff>
--- a/Accompagnement de sont enfant sur internet en toute securité/Securite_Internet_Enfants_Presentation_2  -  Réparation  -  Réparation.pptx
+++ b/Accompagnement de sont enfant sur internet en toute securité/Securite_Internet_Enfants_Presentation_2  -  Réparation  -  Réparation.pptx
@@ -2898,7 +2898,7 @@
                 <a:ea typeface="Trebuchet MS" pitchFamily="34" charset="-122"/>
                 <a:cs typeface="Trebuchet MS" pitchFamily="34" charset="-120"/>
               </a:rPr>
-              <a:t xml:space="preserve">✦  </a:t>
+              <a:t>✦  </a:t>
             </a:r>
             <a:r>
               <a:rPr lang="en-US" sz="1200" b="1" dirty="0">
@@ -3395,6 +3395,46 @@
               <a:t>Sans jugement</a:t>
             </a:r>
             <a:endParaRPr lang="en-US" sz="850" dirty="0"/>
+          </a:p>
+        </p:txBody>
+      </p:sp>
+      <p:sp>
+        <p:nvSpPr>
+          <p:cNvPr id="29" name="ZoneTexte 28">
+            <a:extLst>
+              <a:ext uri="{FF2B5EF4-FFF2-40B4-BE49-F238E27FC236}">
+                <a16:creationId xmlns:a16="http://schemas.microsoft.com/office/drawing/2014/main" id="{17F10437-F8B8-E424-DB7B-463AEB906517}"/>
+              </a:ext>
+            </a:extLst>
+          </p:cNvPr>
+          <p:cNvSpPr txBox="1"/>
+          <p:nvPr/>
+        </p:nvSpPr>
+        <p:spPr>
+          <a:xfrm>
+            <a:off x="0" y="4864100"/>
+            <a:ext cx="9144000" cy="230832"/>
+          </a:xfrm>
+          <a:prstGeom prst="rect">
+            <a:avLst/>
+          </a:prstGeom>
+          <a:noFill/>
+        </p:spPr>
+        <p:txBody>
+          <a:bodyPr vert="horz" rtlCol="0">
+            <a:spAutoFit/>
+          </a:bodyPr>
+          <a:lstStyle/>
+          <a:p>
+            <a:pPr algn="ctr"/>
+            <a:r>
+              <a:rPr lang="fr-FR" sz="900">
+                <a:solidFill>
+                  <a:srgbClr val="B4B4B4"/>
+                </a:solidFill>
+              </a:rPr>
+              <a:t>(c) titi_23 - mediateur-numerique.github.io - Reproduction interdite sans autorisation</a:t>
+            </a:r>
           </a:p>
         </p:txBody>
       </p:sp>
@@ -4435,7 +4475,7 @@
                   </a:extLst>
                 </a:hlinkClick>
               </a:rPr>
-              <a:t xml:space="preserve">◀ </a:t>
+              <a:t>◀ </a:t>
             </a:r>
             <a:r>
               <a:rPr lang="en-US" sz="900" u="sng" dirty="0">
@@ -4555,7 +4595,7 @@
                   </a:extLst>
                 </a:hlinkClick>
               </a:rPr>
-              <a:t xml:space="preserve"> ▶</a:t>
+              <a:t> ▶</a:t>
             </a:r>
             <a:endParaRPr lang="en-US" sz="900" dirty="0"/>
           </a:p>
@@ -4642,6 +4682,46 @@
               <a:t>☰ Menu</a:t>
             </a:r>
             <a:endParaRPr lang="en-US" sz="750" dirty="0"/>
+          </a:p>
+        </p:txBody>
+      </p:sp>
+      <p:sp>
+        <p:nvSpPr>
+          <p:cNvPr id="35" name="ZoneTexte 34">
+            <a:extLst>
+              <a:ext uri="{FF2B5EF4-FFF2-40B4-BE49-F238E27FC236}">
+                <a16:creationId xmlns:a16="http://schemas.microsoft.com/office/drawing/2014/main" id="{4E315EFF-8DA5-B7C6-10F8-37B8A4951114}"/>
+              </a:ext>
+            </a:extLst>
+          </p:cNvPr>
+          <p:cNvSpPr txBox="1"/>
+          <p:nvPr/>
+        </p:nvSpPr>
+        <p:spPr>
+          <a:xfrm>
+            <a:off x="0" y="4864100"/>
+            <a:ext cx="9144000" cy="230832"/>
+          </a:xfrm>
+          <a:prstGeom prst="rect">
+            <a:avLst/>
+          </a:prstGeom>
+          <a:noFill/>
+        </p:spPr>
+        <p:txBody>
+          <a:bodyPr vert="horz" rtlCol="0">
+            <a:spAutoFit/>
+          </a:bodyPr>
+          <a:lstStyle/>
+          <a:p>
+            <a:pPr algn="ctr"/>
+            <a:r>
+              <a:rPr lang="fr-FR" sz="900">
+                <a:solidFill>
+                  <a:srgbClr val="B4B4B4"/>
+                </a:solidFill>
+              </a:rPr>
+              <a:t>(c) titi_23 - mediateur-numerique.github.io - Reproduction interdite sans autorisation</a:t>
+            </a:r>
           </a:p>
         </p:txBody>
       </p:sp>
@@ -4972,7 +5052,7 @@
                 <a:ea typeface="Calibri" pitchFamily="34" charset="-122"/>
                 <a:cs typeface="Calibri" pitchFamily="34" charset="-120"/>
               </a:rPr>
-              <a:t xml:space="preserve">Google Family Link  </a:t>
+              <a:t>Google Family Link  </a:t>
             </a:r>
             <a:r>
               <a:rPr lang="en-US" sz="1000" dirty="0">
@@ -5091,7 +5171,7 @@
                 <a:ea typeface="Calibri" pitchFamily="34" charset="-122"/>
                 <a:cs typeface="Calibri" pitchFamily="34" charset="-120"/>
               </a:rPr>
-              <a:t xml:space="preserve">Temps d'écran (Apple)  </a:t>
+              <a:t>Temps d'écran (Apple)  </a:t>
             </a:r>
             <a:r>
               <a:rPr lang="en-US" sz="1000" dirty="0">
@@ -5210,7 +5290,7 @@
                 <a:ea typeface="Calibri" pitchFamily="34" charset="-122"/>
                 <a:cs typeface="Calibri" pitchFamily="34" charset="-120"/>
               </a:rPr>
-              <a:t xml:space="preserve">Microsoft Family Safety  </a:t>
+              <a:t>Microsoft Family Safety  </a:t>
             </a:r>
             <a:r>
               <a:rPr lang="en-US" sz="1000" dirty="0">
@@ -5329,7 +5409,7 @@
                 <a:ea typeface="Calibri" pitchFamily="34" charset="-122"/>
                 <a:cs typeface="Calibri" pitchFamily="34" charset="-120"/>
               </a:rPr>
-              <a:t xml:space="preserve">Qustodio / Net Nanny  </a:t>
+              <a:t>Qustodio / Net Nanny  </a:t>
             </a:r>
             <a:r>
               <a:rPr lang="en-US" sz="1000" dirty="0">
@@ -5448,7 +5528,7 @@
                 <a:ea typeface="Calibri" pitchFamily="34" charset="-122"/>
                 <a:cs typeface="Calibri" pitchFamily="34" charset="-120"/>
               </a:rPr>
-              <a:t xml:space="preserve">Filtres de la box  </a:t>
+              <a:t>Filtres de la box  </a:t>
             </a:r>
             <a:r>
               <a:rPr lang="en-US" sz="1000" dirty="0">
@@ -5845,7 +5925,7 @@
                   </a:extLst>
                 </a:hlinkClick>
               </a:rPr>
-              <a:t xml:space="preserve">◀ </a:t>
+              <a:t>◀ </a:t>
             </a:r>
             <a:r>
               <a:rPr lang="en-US" sz="900" u="sng" dirty="0">
@@ -5965,7 +6045,7 @@
                   </a:extLst>
                 </a:hlinkClick>
               </a:rPr>
-              <a:t xml:space="preserve"> ▶</a:t>
+              <a:t> ▶</a:t>
             </a:r>
             <a:endParaRPr lang="en-US" sz="900" dirty="0"/>
           </a:p>
@@ -6052,6 +6132,46 @@
               <a:t>☰ Menu</a:t>
             </a:r>
             <a:endParaRPr lang="en-US" sz="750" dirty="0"/>
+          </a:p>
+        </p:txBody>
+      </p:sp>
+      <p:sp>
+        <p:nvSpPr>
+          <p:cNvPr id="35" name="ZoneTexte 34">
+            <a:extLst>
+              <a:ext uri="{FF2B5EF4-FFF2-40B4-BE49-F238E27FC236}">
+                <a16:creationId xmlns:a16="http://schemas.microsoft.com/office/drawing/2014/main" id="{6986E501-5765-061E-A617-E16D3B167E64}"/>
+              </a:ext>
+            </a:extLst>
+          </p:cNvPr>
+          <p:cNvSpPr txBox="1"/>
+          <p:nvPr/>
+        </p:nvSpPr>
+        <p:spPr>
+          <a:xfrm>
+            <a:off x="0" y="4864100"/>
+            <a:ext cx="9144000" cy="230832"/>
+          </a:xfrm>
+          <a:prstGeom prst="rect">
+            <a:avLst/>
+          </a:prstGeom>
+          <a:noFill/>
+        </p:spPr>
+        <p:txBody>
+          <a:bodyPr vert="horz" rtlCol="0">
+            <a:spAutoFit/>
+          </a:bodyPr>
+          <a:lstStyle/>
+          <a:p>
+            <a:pPr algn="ctr"/>
+            <a:r>
+              <a:rPr lang="fr-FR" sz="900">
+                <a:solidFill>
+                  <a:srgbClr val="B4B4B4"/>
+                </a:solidFill>
+              </a:rPr>
+              <a:t>(c) titi_23 - mediateur-numerique.github.io - Reproduction interdite sans autorisation</a:t>
+            </a:r>
           </a:p>
         </p:txBody>
       </p:sp>
@@ -7303,7 +7423,7 @@
                 <a:ea typeface="Calibri" pitchFamily="34" charset="-122"/>
                 <a:cs typeface="Calibri" pitchFamily="34" charset="-120"/>
               </a:rPr>
-              <a:t xml:space="preserve">⚠  En cas de doute : </a:t>
+              <a:t>⚠  En cas de doute : </a:t>
             </a:r>
             <a:r>
               <a:rPr lang="en-US" sz="1200" dirty="0">
@@ -7464,7 +7584,7 @@
                   </a:extLst>
                 </a:hlinkClick>
               </a:rPr>
-              <a:t xml:space="preserve">◀ </a:t>
+              <a:t>◀ </a:t>
             </a:r>
             <a:r>
               <a:rPr lang="en-US" sz="900" u="sng" dirty="0">
@@ -7584,7 +7704,7 @@
                   </a:extLst>
                 </a:hlinkClick>
               </a:rPr>
-              <a:t xml:space="preserve"> ▶</a:t>
+              <a:t> ▶</a:t>
             </a:r>
             <a:endParaRPr lang="en-US" sz="900" dirty="0"/>
           </a:p>
@@ -7671,6 +7791,46 @@
               <a:t>☰ Menu</a:t>
             </a:r>
             <a:endParaRPr lang="en-US" sz="750" dirty="0"/>
+          </a:p>
+        </p:txBody>
+      </p:sp>
+      <p:sp>
+        <p:nvSpPr>
+          <p:cNvPr id="46" name="ZoneTexte 45">
+            <a:extLst>
+              <a:ext uri="{FF2B5EF4-FFF2-40B4-BE49-F238E27FC236}">
+                <a16:creationId xmlns:a16="http://schemas.microsoft.com/office/drawing/2014/main" id="{D46B519C-B26E-631D-EC3C-15BB32CF168F}"/>
+              </a:ext>
+            </a:extLst>
+          </p:cNvPr>
+          <p:cNvSpPr txBox="1"/>
+          <p:nvPr/>
+        </p:nvSpPr>
+        <p:spPr>
+          <a:xfrm>
+            <a:off x="0" y="4864100"/>
+            <a:ext cx="9144000" cy="230832"/>
+          </a:xfrm>
+          <a:prstGeom prst="rect">
+            <a:avLst/>
+          </a:prstGeom>
+          <a:noFill/>
+        </p:spPr>
+        <p:txBody>
+          <a:bodyPr vert="horz" rtlCol="0">
+            <a:spAutoFit/>
+          </a:bodyPr>
+          <a:lstStyle/>
+          <a:p>
+            <a:pPr algn="ctr"/>
+            <a:r>
+              <a:rPr lang="fr-FR" sz="900">
+                <a:solidFill>
+                  <a:srgbClr val="B4B4B4"/>
+                </a:solidFill>
+              </a:rPr>
+              <a:t>(c) titi_23 - mediateur-numerique.github.io - Reproduction interdite sans autorisation</a:t>
+            </a:r>
           </a:p>
         </p:txBody>
       </p:sp>
@@ -7967,7 +8127,7 @@
                 <a:ea typeface="Calibri" pitchFamily="34" charset="-122"/>
                 <a:cs typeface="Calibri" pitchFamily="34" charset="-120"/>
               </a:rPr>
-              <a:t xml:space="preserve">Contexte : </a:t>
+              <a:t>Contexte : </a:t>
             </a:r>
             <a:r>
               <a:rPr lang="en-US" sz="1100" dirty="0">
@@ -8310,7 +8470,7 @@
                 <a:ea typeface="Trebuchet MS" pitchFamily="34" charset="-122"/>
                 <a:cs typeface="Trebuchet MS" pitchFamily="34" charset="-120"/>
               </a:rPr>
-              <a:t xml:space="preserve">✔ Réponse : À RISQUE — </a:t>
+              <a:t>✔ Réponse : À RISQUE — </a:t>
             </a:r>
             <a:r>
               <a:rPr lang="en-US" sz="1150" b="1" dirty="0">
@@ -8573,7 +8733,7 @@
                   </a:extLst>
                 </a:hlinkClick>
               </a:rPr>
-              <a:t xml:space="preserve">◀ </a:t>
+              <a:t>◀ </a:t>
             </a:r>
             <a:r>
               <a:rPr lang="en-US" sz="900" u="sng" dirty="0">
@@ -8693,7 +8853,7 @@
                   </a:extLst>
                 </a:hlinkClick>
               </a:rPr>
-              <a:t xml:space="preserve"> ▶</a:t>
+              <a:t> ▶</a:t>
             </a:r>
             <a:endParaRPr lang="en-US" sz="900" dirty="0"/>
           </a:p>
@@ -8780,6 +8940,46 @@
               <a:t>☰ Menu</a:t>
             </a:r>
             <a:endParaRPr lang="en-US" sz="750" dirty="0"/>
+          </a:p>
+        </p:txBody>
+      </p:sp>
+      <p:sp>
+        <p:nvSpPr>
+          <p:cNvPr id="28" name="ZoneTexte 27">
+            <a:extLst>
+              <a:ext uri="{FF2B5EF4-FFF2-40B4-BE49-F238E27FC236}">
+                <a16:creationId xmlns:a16="http://schemas.microsoft.com/office/drawing/2014/main" id="{1C58D43A-C665-6FE0-6AF1-C71DC72797AC}"/>
+              </a:ext>
+            </a:extLst>
+          </p:cNvPr>
+          <p:cNvSpPr txBox="1"/>
+          <p:nvPr/>
+        </p:nvSpPr>
+        <p:spPr>
+          <a:xfrm>
+            <a:off x="0" y="4864100"/>
+            <a:ext cx="9144000" cy="230832"/>
+          </a:xfrm>
+          <a:prstGeom prst="rect">
+            <a:avLst/>
+          </a:prstGeom>
+          <a:noFill/>
+        </p:spPr>
+        <p:txBody>
+          <a:bodyPr vert="horz" rtlCol="0">
+            <a:spAutoFit/>
+          </a:bodyPr>
+          <a:lstStyle/>
+          <a:p>
+            <a:pPr algn="ctr"/>
+            <a:r>
+              <a:rPr lang="fr-FR" sz="900">
+                <a:solidFill>
+                  <a:srgbClr val="B4B4B4"/>
+                </a:solidFill>
+              </a:rPr>
+              <a:t>(c) titi_23 - mediateur-numerique.github.io - Reproduction interdite sans autorisation</a:t>
+            </a:r>
           </a:p>
         </p:txBody>
       </p:sp>
@@ -8809,7 +9009,7 @@
                             </p:stCondLst>
                             <p:childTnLst>
                               <p:par>
-                                <p:cTn id="5" presetID="10" presetClass="entr" presetSubtype="0" fill="hold" grpId="0" nodeType="clickEffect">
+                                <p:cTn id="5" presetID="10" presetClass="entr" presetSubtype="0" fill="hold" nodeType="clickEffect">
                                   <p:stCondLst>
                                     <p:cond delay="0"/>
                                   </p:stCondLst>
@@ -8844,7 +9044,7 @@
                                 </p:cTn>
                               </p:par>
                               <p:par>
-                                <p:cTn id="8" presetID="10" presetClass="entr" presetSubtype="0" fill="hold" grpId="0" nodeType="withEffect">
+                                <p:cTn id="8" presetID="10" presetClass="entr" presetSubtype="0" fill="hold" nodeType="withEffect">
                                   <p:stCondLst>
                                     <p:cond delay="0"/>
                                   </p:stCondLst>
@@ -8879,7 +9079,7 @@
                                 </p:cTn>
                               </p:par>
                               <p:par>
-                                <p:cTn id="11" presetID="10" presetClass="entr" presetSubtype="0" fill="hold" grpId="0" nodeType="withEffect">
+                                <p:cTn id="11" presetID="10" presetClass="entr" presetSubtype="0" fill="hold" nodeType="withEffect">
                                   <p:stCondLst>
                                     <p:cond delay="0"/>
                                   </p:stCondLst>
@@ -9229,7 +9429,7 @@
                 <a:ea typeface="Calibri" pitchFamily="34" charset="-122"/>
                 <a:cs typeface="Calibri" pitchFamily="34" charset="-120"/>
               </a:rPr>
-              <a:t xml:space="preserve">Contexte : </a:t>
+              <a:t>Contexte : </a:t>
             </a:r>
             <a:r>
               <a:rPr lang="en-US" sz="1100" dirty="0">
@@ -9572,7 +9772,7 @@
                 <a:ea typeface="Trebuchet MS" pitchFamily="34" charset="-122"/>
                 <a:cs typeface="Trebuchet MS" pitchFamily="34" charset="-120"/>
               </a:rPr>
-              <a:t xml:space="preserve">✔ Réponse : SANS DANGER — </a:t>
+              <a:t>✔ Réponse : SANS DANGER — </a:t>
             </a:r>
             <a:r>
               <a:rPr lang="en-US" sz="1150" b="1" dirty="0">
@@ -9835,7 +10035,7 @@
                   </a:extLst>
                 </a:hlinkClick>
               </a:rPr>
-              <a:t xml:space="preserve">◀ </a:t>
+              <a:t>◀ </a:t>
             </a:r>
             <a:r>
               <a:rPr lang="en-US" sz="900" u="sng" dirty="0">
@@ -9955,7 +10155,7 @@
                   </a:extLst>
                 </a:hlinkClick>
               </a:rPr>
-              <a:t xml:space="preserve"> ▶</a:t>
+              <a:t> ▶</a:t>
             </a:r>
             <a:endParaRPr lang="en-US" sz="900" dirty="0"/>
           </a:p>
@@ -10042,6 +10242,46 @@
               <a:t>☰ Menu</a:t>
             </a:r>
             <a:endParaRPr lang="en-US" sz="750" dirty="0"/>
+          </a:p>
+        </p:txBody>
+      </p:sp>
+      <p:sp>
+        <p:nvSpPr>
+          <p:cNvPr id="28" name="ZoneTexte 27">
+            <a:extLst>
+              <a:ext uri="{FF2B5EF4-FFF2-40B4-BE49-F238E27FC236}">
+                <a16:creationId xmlns:a16="http://schemas.microsoft.com/office/drawing/2014/main" id="{DBCF8A49-F957-0513-E5EA-8FE27C93E1B8}"/>
+              </a:ext>
+            </a:extLst>
+          </p:cNvPr>
+          <p:cNvSpPr txBox="1"/>
+          <p:nvPr/>
+        </p:nvSpPr>
+        <p:spPr>
+          <a:xfrm>
+            <a:off x="0" y="4864100"/>
+            <a:ext cx="9144000" cy="230832"/>
+          </a:xfrm>
+          <a:prstGeom prst="rect">
+            <a:avLst/>
+          </a:prstGeom>
+          <a:noFill/>
+        </p:spPr>
+        <p:txBody>
+          <a:bodyPr vert="horz" rtlCol="0">
+            <a:spAutoFit/>
+          </a:bodyPr>
+          <a:lstStyle/>
+          <a:p>
+            <a:pPr algn="ctr"/>
+            <a:r>
+              <a:rPr lang="fr-FR" sz="900">
+                <a:solidFill>
+                  <a:srgbClr val="B4B4B4"/>
+                </a:solidFill>
+              </a:rPr>
+              <a:t>(c) titi_23 - mediateur-numerique.github.io - Reproduction interdite sans autorisation</a:t>
+            </a:r>
           </a:p>
         </p:txBody>
       </p:sp>
@@ -10071,7 +10311,7 @@
                             </p:stCondLst>
                             <p:childTnLst>
                               <p:par>
-                                <p:cTn id="5" presetID="10" presetClass="entr" presetSubtype="0" fill="hold" grpId="0" nodeType="clickEffect">
+                                <p:cTn id="5" presetID="10" presetClass="entr" presetSubtype="0" fill="hold" nodeType="clickEffect">
                                   <p:stCondLst>
                                     <p:cond delay="0"/>
                                   </p:stCondLst>
@@ -10106,7 +10346,7 @@
                                 </p:cTn>
                               </p:par>
                               <p:par>
-                                <p:cTn id="8" presetID="10" presetClass="entr" presetSubtype="0" fill="hold" grpId="0" nodeType="withEffect">
+                                <p:cTn id="8" presetID="10" presetClass="entr" presetSubtype="0" fill="hold" nodeType="withEffect">
                                   <p:stCondLst>
                                     <p:cond delay="0"/>
                                   </p:stCondLst>
@@ -10141,7 +10381,7 @@
                                 </p:cTn>
                               </p:par>
                               <p:par>
-                                <p:cTn id="11" presetID="10" presetClass="entr" presetSubtype="0" fill="hold" grpId="0" nodeType="withEffect">
+                                <p:cTn id="11" presetID="10" presetClass="entr" presetSubtype="0" fill="hold" nodeType="withEffect">
                                   <p:stCondLst>
                                     <p:cond delay="0"/>
                                   </p:stCondLst>
@@ -10491,7 +10731,7 @@
                 <a:ea typeface="Calibri" pitchFamily="34" charset="-122"/>
                 <a:cs typeface="Calibri" pitchFamily="34" charset="-120"/>
               </a:rPr>
-              <a:t xml:space="preserve">Contexte : </a:t>
+              <a:t>Contexte : </a:t>
             </a:r>
             <a:r>
               <a:rPr lang="en-US" sz="1100" dirty="0">
@@ -10834,7 +11074,7 @@
                 <a:ea typeface="Trebuchet MS" pitchFamily="34" charset="-122"/>
                 <a:cs typeface="Trebuchet MS" pitchFamily="34" charset="-120"/>
               </a:rPr>
-              <a:t xml:space="preserve">✔ Réponse : À RISQUE — </a:t>
+              <a:t>✔ Réponse : À RISQUE — </a:t>
             </a:r>
             <a:r>
               <a:rPr lang="en-US" sz="1150" b="1" dirty="0">
@@ -11097,7 +11337,7 @@
                   </a:extLst>
                 </a:hlinkClick>
               </a:rPr>
-              <a:t xml:space="preserve">◀ </a:t>
+              <a:t>◀ </a:t>
             </a:r>
             <a:r>
               <a:rPr lang="en-US" sz="900" u="sng" dirty="0">
@@ -11217,7 +11457,7 @@
                   </a:extLst>
                 </a:hlinkClick>
               </a:rPr>
-              <a:t xml:space="preserve"> ▶</a:t>
+              <a:t> ▶</a:t>
             </a:r>
             <a:endParaRPr lang="en-US" sz="900" dirty="0"/>
           </a:p>
@@ -11304,6 +11544,46 @@
               <a:t>☰ Menu</a:t>
             </a:r>
             <a:endParaRPr lang="en-US" sz="750" dirty="0"/>
+          </a:p>
+        </p:txBody>
+      </p:sp>
+      <p:sp>
+        <p:nvSpPr>
+          <p:cNvPr id="28" name="ZoneTexte 27">
+            <a:extLst>
+              <a:ext uri="{FF2B5EF4-FFF2-40B4-BE49-F238E27FC236}">
+                <a16:creationId xmlns:a16="http://schemas.microsoft.com/office/drawing/2014/main" id="{EF63D977-320F-CF37-98D6-F484BCD70916}"/>
+              </a:ext>
+            </a:extLst>
+          </p:cNvPr>
+          <p:cNvSpPr txBox="1"/>
+          <p:nvPr/>
+        </p:nvSpPr>
+        <p:spPr>
+          <a:xfrm>
+            <a:off x="0" y="4864100"/>
+            <a:ext cx="9144000" cy="230832"/>
+          </a:xfrm>
+          <a:prstGeom prst="rect">
+            <a:avLst/>
+          </a:prstGeom>
+          <a:noFill/>
+        </p:spPr>
+        <p:txBody>
+          <a:bodyPr vert="horz" rtlCol="0">
+            <a:spAutoFit/>
+          </a:bodyPr>
+          <a:lstStyle/>
+          <a:p>
+            <a:pPr algn="ctr"/>
+            <a:r>
+              <a:rPr lang="fr-FR" sz="900">
+                <a:solidFill>
+                  <a:srgbClr val="B4B4B4"/>
+                </a:solidFill>
+              </a:rPr>
+              <a:t>(c) titi_23 - mediateur-numerique.github.io - Reproduction interdite sans autorisation</a:t>
+            </a:r>
           </a:p>
         </p:txBody>
       </p:sp>
@@ -11333,7 +11613,7 @@
                             </p:stCondLst>
                             <p:childTnLst>
                               <p:par>
-                                <p:cTn id="5" presetID="10" presetClass="entr" presetSubtype="0" fill="hold" grpId="0" nodeType="clickEffect">
+                                <p:cTn id="5" presetID="10" presetClass="entr" presetSubtype="0" fill="hold" nodeType="clickEffect">
                                   <p:stCondLst>
                                     <p:cond delay="0"/>
                                   </p:stCondLst>
@@ -11368,7 +11648,7 @@
                                 </p:cTn>
                               </p:par>
                               <p:par>
-                                <p:cTn id="8" presetID="10" presetClass="entr" presetSubtype="0" fill="hold" grpId="0" nodeType="withEffect">
+                                <p:cTn id="8" presetID="10" presetClass="entr" presetSubtype="0" fill="hold" nodeType="withEffect">
                                   <p:stCondLst>
                                     <p:cond delay="0"/>
                                   </p:stCondLst>
@@ -11403,7 +11683,7 @@
                                 </p:cTn>
                               </p:par>
                               <p:par>
-                                <p:cTn id="11" presetID="10" presetClass="entr" presetSubtype="0" fill="hold" grpId="0" nodeType="withEffect">
+                                <p:cTn id="11" presetID="10" presetClass="entr" presetSubtype="0" fill="hold" nodeType="withEffect">
                                   <p:stCondLst>
                                     <p:cond delay="0"/>
                                   </p:stCondLst>
@@ -11753,7 +12033,7 @@
                 <a:ea typeface="Calibri" pitchFamily="34" charset="-122"/>
                 <a:cs typeface="Calibri" pitchFamily="34" charset="-120"/>
               </a:rPr>
-              <a:t xml:space="preserve">Contexte : </a:t>
+              <a:t>Contexte : </a:t>
             </a:r>
             <a:r>
               <a:rPr lang="en-US" sz="1100" dirty="0">
@@ -12096,7 +12376,7 @@
                 <a:ea typeface="Trebuchet MS" pitchFamily="34" charset="-122"/>
                 <a:cs typeface="Trebuchet MS" pitchFamily="34" charset="-120"/>
               </a:rPr>
-              <a:t xml:space="preserve">✔ Réponse : SANS DANGER — </a:t>
+              <a:t>✔ Réponse : SANS DANGER — </a:t>
             </a:r>
             <a:r>
               <a:rPr lang="en-US" sz="1150" b="1" dirty="0">
@@ -12359,7 +12639,7 @@
                   </a:extLst>
                 </a:hlinkClick>
               </a:rPr>
-              <a:t xml:space="preserve">◀ </a:t>
+              <a:t>◀ </a:t>
             </a:r>
             <a:r>
               <a:rPr lang="en-US" sz="900" u="sng" dirty="0">
@@ -12479,7 +12759,7 @@
                   </a:extLst>
                 </a:hlinkClick>
               </a:rPr>
-              <a:t xml:space="preserve"> ▶</a:t>
+              <a:t> ▶</a:t>
             </a:r>
             <a:endParaRPr lang="en-US" sz="900" dirty="0"/>
           </a:p>
@@ -12566,6 +12846,46 @@
               <a:t>☰ Menu</a:t>
             </a:r>
             <a:endParaRPr lang="en-US" sz="750" dirty="0"/>
+          </a:p>
+        </p:txBody>
+      </p:sp>
+      <p:sp>
+        <p:nvSpPr>
+          <p:cNvPr id="28" name="ZoneTexte 27">
+            <a:extLst>
+              <a:ext uri="{FF2B5EF4-FFF2-40B4-BE49-F238E27FC236}">
+                <a16:creationId xmlns:a16="http://schemas.microsoft.com/office/drawing/2014/main" id="{8FC8A972-497C-7C24-5B35-1897965A487D}"/>
+              </a:ext>
+            </a:extLst>
+          </p:cNvPr>
+          <p:cNvSpPr txBox="1"/>
+          <p:nvPr/>
+        </p:nvSpPr>
+        <p:spPr>
+          <a:xfrm>
+            <a:off x="0" y="4864100"/>
+            <a:ext cx="9144000" cy="230832"/>
+          </a:xfrm>
+          <a:prstGeom prst="rect">
+            <a:avLst/>
+          </a:prstGeom>
+          <a:noFill/>
+        </p:spPr>
+        <p:txBody>
+          <a:bodyPr vert="horz" rtlCol="0">
+            <a:spAutoFit/>
+          </a:bodyPr>
+          <a:lstStyle/>
+          <a:p>
+            <a:pPr algn="ctr"/>
+            <a:r>
+              <a:rPr lang="fr-FR" sz="900">
+                <a:solidFill>
+                  <a:srgbClr val="B4B4B4"/>
+                </a:solidFill>
+              </a:rPr>
+              <a:t>(c) titi_23 - mediateur-numerique.github.io - Reproduction interdite sans autorisation</a:t>
+            </a:r>
           </a:p>
         </p:txBody>
       </p:sp>
@@ -12595,7 +12915,7 @@
                             </p:stCondLst>
                             <p:childTnLst>
                               <p:par>
-                                <p:cTn id="5" presetID="10" presetClass="entr" presetSubtype="0" fill="hold" grpId="0" nodeType="clickEffect">
+                                <p:cTn id="5" presetID="10" presetClass="entr" presetSubtype="0" fill="hold" nodeType="clickEffect">
                                   <p:stCondLst>
                                     <p:cond delay="0"/>
                                   </p:stCondLst>
@@ -12630,7 +12950,7 @@
                                 </p:cTn>
                               </p:par>
                               <p:par>
-                                <p:cTn id="8" presetID="10" presetClass="entr" presetSubtype="0" fill="hold" grpId="0" nodeType="withEffect">
+                                <p:cTn id="8" presetID="10" presetClass="entr" presetSubtype="0" fill="hold" nodeType="withEffect">
                                   <p:stCondLst>
                                     <p:cond delay="0"/>
                                   </p:stCondLst>
@@ -12665,7 +12985,7 @@
                                 </p:cTn>
                               </p:par>
                               <p:par>
-                                <p:cTn id="11" presetID="10" presetClass="entr" presetSubtype="0" fill="hold" grpId="0" nodeType="withEffect">
+                                <p:cTn id="11" presetID="10" presetClass="entr" presetSubtype="0" fill="hold" nodeType="withEffect">
                                   <p:stCondLst>
                                     <p:cond delay="0"/>
                                   </p:stCondLst>
@@ -13015,7 +13335,7 @@
                 <a:ea typeface="Calibri" pitchFamily="34" charset="-122"/>
                 <a:cs typeface="Calibri" pitchFamily="34" charset="-120"/>
               </a:rPr>
-              <a:t xml:space="preserve">Contexte : </a:t>
+              <a:t>Contexte : </a:t>
             </a:r>
             <a:r>
               <a:rPr lang="en-US" sz="1100" dirty="0">
@@ -13358,7 +13678,7 @@
                 <a:ea typeface="Trebuchet MS" pitchFamily="34" charset="-122"/>
                 <a:cs typeface="Trebuchet MS" pitchFamily="34" charset="-120"/>
               </a:rPr>
-              <a:t xml:space="preserve">✔ Réponse : À RISQUE — </a:t>
+              <a:t>✔ Réponse : À RISQUE — </a:t>
             </a:r>
             <a:r>
               <a:rPr lang="en-US" sz="1150" b="1" dirty="0">
@@ -13621,7 +13941,7 @@
                   </a:extLst>
                 </a:hlinkClick>
               </a:rPr>
-              <a:t xml:space="preserve">◀ </a:t>
+              <a:t>◀ </a:t>
             </a:r>
             <a:r>
               <a:rPr lang="en-US" sz="900" u="sng" dirty="0">
@@ -13741,7 +14061,7 @@
                   </a:extLst>
                 </a:hlinkClick>
               </a:rPr>
-              <a:t xml:space="preserve"> ▶</a:t>
+              <a:t> ▶</a:t>
             </a:r>
             <a:endParaRPr lang="en-US" sz="900" dirty="0"/>
           </a:p>
@@ -13828,6 +14148,46 @@
               <a:t>☰ Menu</a:t>
             </a:r>
             <a:endParaRPr lang="en-US" sz="750" dirty="0"/>
+          </a:p>
+        </p:txBody>
+      </p:sp>
+      <p:sp>
+        <p:nvSpPr>
+          <p:cNvPr id="28" name="ZoneTexte 27">
+            <a:extLst>
+              <a:ext uri="{FF2B5EF4-FFF2-40B4-BE49-F238E27FC236}">
+                <a16:creationId xmlns:a16="http://schemas.microsoft.com/office/drawing/2014/main" id="{BD2B404D-ABB4-A5A2-45CA-3AA7F8EAA74A}"/>
+              </a:ext>
+            </a:extLst>
+          </p:cNvPr>
+          <p:cNvSpPr txBox="1"/>
+          <p:nvPr/>
+        </p:nvSpPr>
+        <p:spPr>
+          <a:xfrm>
+            <a:off x="0" y="4864100"/>
+            <a:ext cx="9144000" cy="230832"/>
+          </a:xfrm>
+          <a:prstGeom prst="rect">
+            <a:avLst/>
+          </a:prstGeom>
+          <a:noFill/>
+        </p:spPr>
+        <p:txBody>
+          <a:bodyPr vert="horz" rtlCol="0">
+            <a:spAutoFit/>
+          </a:bodyPr>
+          <a:lstStyle/>
+          <a:p>
+            <a:pPr algn="ctr"/>
+            <a:r>
+              <a:rPr lang="fr-FR" sz="900">
+                <a:solidFill>
+                  <a:srgbClr val="B4B4B4"/>
+                </a:solidFill>
+              </a:rPr>
+              <a:t>(c) titi_23 - mediateur-numerique.github.io - Reproduction interdite sans autorisation</a:t>
+            </a:r>
           </a:p>
         </p:txBody>
       </p:sp>
@@ -13857,7 +14217,7 @@
                             </p:stCondLst>
                             <p:childTnLst>
                               <p:par>
-                                <p:cTn id="5" presetID="10" presetClass="entr" presetSubtype="0" fill="hold" grpId="0" nodeType="clickEffect">
+                                <p:cTn id="5" presetID="10" presetClass="entr" presetSubtype="0" fill="hold" nodeType="clickEffect">
                                   <p:stCondLst>
                                     <p:cond delay="0"/>
                                   </p:stCondLst>
@@ -13892,7 +14252,7 @@
                                 </p:cTn>
                               </p:par>
                               <p:par>
-                                <p:cTn id="8" presetID="10" presetClass="entr" presetSubtype="0" fill="hold" grpId="0" nodeType="withEffect">
+                                <p:cTn id="8" presetID="10" presetClass="entr" presetSubtype="0" fill="hold" nodeType="withEffect">
                                   <p:stCondLst>
                                     <p:cond delay="0"/>
                                   </p:stCondLst>
@@ -13927,7 +14287,7 @@
                                 </p:cTn>
                               </p:par>
                               <p:par>
-                                <p:cTn id="11" presetID="10" presetClass="entr" presetSubtype="0" fill="hold" grpId="0" nodeType="withEffect">
+                                <p:cTn id="11" presetID="10" presetClass="entr" presetSubtype="0" fill="hold" nodeType="withEffect">
                                   <p:stCondLst>
                                     <p:cond delay="0"/>
                                   </p:stCondLst>
@@ -15365,7 +15725,7 @@
                   </a:extLst>
                 </a:hlinkClick>
               </a:rPr>
-              <a:t xml:space="preserve">◀ </a:t>
+              <a:t>◀ </a:t>
             </a:r>
             <a:r>
               <a:rPr lang="en-US" sz="900" u="sng" dirty="0">
@@ -15485,7 +15845,7 @@
                   </a:extLst>
                 </a:hlinkClick>
               </a:rPr>
-              <a:t xml:space="preserve"> ▶</a:t>
+              <a:t> ▶</a:t>
             </a:r>
             <a:endParaRPr lang="en-US" sz="900" dirty="0"/>
           </a:p>
@@ -15572,6 +15932,46 @@
               <a:t>☰ Menu</a:t>
             </a:r>
             <a:endParaRPr lang="en-US" sz="750" dirty="0"/>
+          </a:p>
+        </p:txBody>
+      </p:sp>
+      <p:sp>
+        <p:nvSpPr>
+          <p:cNvPr id="45" name="ZoneTexte 44">
+            <a:extLst>
+              <a:ext uri="{FF2B5EF4-FFF2-40B4-BE49-F238E27FC236}">
+                <a16:creationId xmlns:a16="http://schemas.microsoft.com/office/drawing/2014/main" id="{143D1046-9EA6-AA19-9EF5-82D126A96082}"/>
+              </a:ext>
+            </a:extLst>
+          </p:cNvPr>
+          <p:cNvSpPr txBox="1"/>
+          <p:nvPr/>
+        </p:nvSpPr>
+        <p:spPr>
+          <a:xfrm>
+            <a:off x="0" y="4864100"/>
+            <a:ext cx="9144000" cy="230832"/>
+          </a:xfrm>
+          <a:prstGeom prst="rect">
+            <a:avLst/>
+          </a:prstGeom>
+          <a:noFill/>
+        </p:spPr>
+        <p:txBody>
+          <a:bodyPr vert="horz" rtlCol="0">
+            <a:spAutoFit/>
+          </a:bodyPr>
+          <a:lstStyle/>
+          <a:p>
+            <a:pPr algn="ctr"/>
+            <a:r>
+              <a:rPr lang="fr-FR" sz="900">
+                <a:solidFill>
+                  <a:srgbClr val="B4B4B4"/>
+                </a:solidFill>
+              </a:rPr>
+              <a:t>(c) titi_23 - mediateur-numerique.github.io - Reproduction interdite sans autorisation</a:t>
+            </a:r>
           </a:p>
         </p:txBody>
       </p:sp>
@@ -16907,7 +17307,7 @@
                   </a:extLst>
                 </a:hlinkClick>
               </a:rPr>
-              <a:t xml:space="preserve">◀ </a:t>
+              <a:t>◀ </a:t>
             </a:r>
             <a:r>
               <a:rPr lang="en-US" sz="900" u="sng" dirty="0">
@@ -17027,7 +17427,7 @@
                   </a:extLst>
                 </a:hlinkClick>
               </a:rPr>
-              <a:t xml:space="preserve"> ▶</a:t>
+              <a:t> ▶</a:t>
             </a:r>
             <a:endParaRPr lang="en-US" sz="900" dirty="0"/>
           </a:p>
@@ -17114,6 +17514,46 @@
               <a:t>☰ Menu</a:t>
             </a:r>
             <a:endParaRPr lang="en-US" sz="750" dirty="0"/>
+          </a:p>
+        </p:txBody>
+      </p:sp>
+      <p:sp>
+        <p:nvSpPr>
+          <p:cNvPr id="44" name="ZoneTexte 43">
+            <a:extLst>
+              <a:ext uri="{FF2B5EF4-FFF2-40B4-BE49-F238E27FC236}">
+                <a16:creationId xmlns:a16="http://schemas.microsoft.com/office/drawing/2014/main" id="{8D4369C5-3038-69FE-BC95-A097B9E8C527}"/>
+              </a:ext>
+            </a:extLst>
+          </p:cNvPr>
+          <p:cNvSpPr txBox="1"/>
+          <p:nvPr/>
+        </p:nvSpPr>
+        <p:spPr>
+          <a:xfrm>
+            <a:off x="0" y="4864100"/>
+            <a:ext cx="9144000" cy="230832"/>
+          </a:xfrm>
+          <a:prstGeom prst="rect">
+            <a:avLst/>
+          </a:prstGeom>
+          <a:noFill/>
+        </p:spPr>
+        <p:txBody>
+          <a:bodyPr vert="horz" rtlCol="0">
+            <a:spAutoFit/>
+          </a:bodyPr>
+          <a:lstStyle/>
+          <a:p>
+            <a:pPr algn="ctr"/>
+            <a:r>
+              <a:rPr lang="fr-FR" sz="900">
+                <a:solidFill>
+                  <a:srgbClr val="B4B4B4"/>
+                </a:solidFill>
+              </a:rPr>
+              <a:t>(c) titi_23 - mediateur-numerique.github.io - Reproduction interdite sans autorisation</a:t>
+            </a:r>
           </a:p>
         </p:txBody>
       </p:sp>
@@ -17915,7 +18355,7 @@
                 <a:ea typeface="Calibri" pitchFamily="34" charset="-122"/>
                 <a:cs typeface="Calibri" pitchFamily="34" charset="-120"/>
               </a:rPr>
-              <a:t xml:space="preserve">En France, </a:t>
+              <a:t>En France, </a:t>
             </a:r>
             <a:r>
               <a:rPr lang="en-US" sz="1300" b="1" dirty="0">
@@ -17937,7 +18377,7 @@
                 <a:ea typeface="Calibri" pitchFamily="34" charset="-122"/>
                 <a:cs typeface="Calibri" pitchFamily="34" charset="-120"/>
               </a:rPr>
-              <a:t xml:space="preserve"> déjà connecté a été contacté par un inconnu en ligne. Le meilleur filtre reste le </a:t>
+              <a:t> déjà connecté a été contacté par un inconnu en ligne. Le meilleur filtre reste le </a:t>
             </a:r>
             <a:r>
               <a:rPr lang="en-US" sz="1300" b="1" dirty="0">
@@ -18109,7 +18549,7 @@
                   </a:extLst>
                 </a:hlinkClick>
               </a:rPr>
-              <a:t xml:space="preserve">◀ </a:t>
+              <a:t>◀ </a:t>
             </a:r>
             <a:r>
               <a:rPr lang="en-US" sz="900" u="sng" dirty="0">
@@ -18229,7 +18669,7 @@
                   </a:extLst>
                 </a:hlinkClick>
               </a:rPr>
-              <a:t xml:space="preserve"> ▶</a:t>
+              <a:t> ▶</a:t>
             </a:r>
             <a:endParaRPr lang="en-US" sz="900" dirty="0"/>
           </a:p>
@@ -18316,6 +18756,46 @@
               <a:t>☰ Menu</a:t>
             </a:r>
             <a:endParaRPr lang="en-US" sz="750" dirty="0"/>
+          </a:p>
+        </p:txBody>
+      </p:sp>
+      <p:sp>
+        <p:nvSpPr>
+          <p:cNvPr id="33" name="ZoneTexte 32">
+            <a:extLst>
+              <a:ext uri="{FF2B5EF4-FFF2-40B4-BE49-F238E27FC236}">
+                <a16:creationId xmlns:a16="http://schemas.microsoft.com/office/drawing/2014/main" id="{3C215D52-CBAF-52A3-7420-4BDE74B84AC1}"/>
+              </a:ext>
+            </a:extLst>
+          </p:cNvPr>
+          <p:cNvSpPr txBox="1"/>
+          <p:nvPr/>
+        </p:nvSpPr>
+        <p:spPr>
+          <a:xfrm>
+            <a:off x="0" y="4864100"/>
+            <a:ext cx="9144000" cy="230832"/>
+          </a:xfrm>
+          <a:prstGeom prst="rect">
+            <a:avLst/>
+          </a:prstGeom>
+          <a:noFill/>
+        </p:spPr>
+        <p:txBody>
+          <a:bodyPr vert="horz" rtlCol="0">
+            <a:spAutoFit/>
+          </a:bodyPr>
+          <a:lstStyle/>
+          <a:p>
+            <a:pPr algn="ctr"/>
+            <a:r>
+              <a:rPr lang="fr-FR" sz="900">
+                <a:solidFill>
+                  <a:srgbClr val="B4B4B4"/>
+                </a:solidFill>
+              </a:rPr>
+              <a:t>(c) titi_23 - mediateur-numerique.github.io - Reproduction interdite sans autorisation</a:t>
+            </a:r>
           </a:p>
         </p:txBody>
       </p:sp>
@@ -19435,7 +19915,7 @@
                   </a:extLst>
                 </a:hlinkClick>
               </a:rPr>
-              <a:t xml:space="preserve">◀ </a:t>
+              <a:t>◀ </a:t>
             </a:r>
             <a:r>
               <a:rPr lang="en-US" sz="900" u="sng" dirty="0">
@@ -19555,7 +20035,7 @@
                   </a:extLst>
                 </a:hlinkClick>
               </a:rPr>
-              <a:t xml:space="preserve"> ▶</a:t>
+              <a:t> ▶</a:t>
             </a:r>
             <a:endParaRPr lang="en-US" sz="900" dirty="0"/>
           </a:p>
@@ -19642,6 +20122,46 @@
               <a:t>☰ Menu</a:t>
             </a:r>
             <a:endParaRPr lang="en-US" sz="750" dirty="0"/>
+          </a:p>
+        </p:txBody>
+      </p:sp>
+      <p:sp>
+        <p:nvSpPr>
+          <p:cNvPr id="38" name="ZoneTexte 37">
+            <a:extLst>
+              <a:ext uri="{FF2B5EF4-FFF2-40B4-BE49-F238E27FC236}">
+                <a16:creationId xmlns:a16="http://schemas.microsoft.com/office/drawing/2014/main" id="{3FAACA4B-0D39-34FD-AB2E-2281C71A06DD}"/>
+              </a:ext>
+            </a:extLst>
+          </p:cNvPr>
+          <p:cNvSpPr txBox="1"/>
+          <p:nvPr/>
+        </p:nvSpPr>
+        <p:spPr>
+          <a:xfrm>
+            <a:off x="0" y="4864100"/>
+            <a:ext cx="9144000" cy="230832"/>
+          </a:xfrm>
+          <a:prstGeom prst="rect">
+            <a:avLst/>
+          </a:prstGeom>
+          <a:noFill/>
+        </p:spPr>
+        <p:txBody>
+          <a:bodyPr vert="horz" rtlCol="0">
+            <a:spAutoFit/>
+          </a:bodyPr>
+          <a:lstStyle/>
+          <a:p>
+            <a:pPr algn="ctr"/>
+            <a:r>
+              <a:rPr lang="fr-FR" sz="900">
+                <a:solidFill>
+                  <a:srgbClr val="B4B4B4"/>
+                </a:solidFill>
+              </a:rPr>
+              <a:t>(c) titi_23 - mediateur-numerique.github.io - Reproduction interdite sans autorisation</a:t>
+            </a:r>
           </a:p>
         </p:txBody>
       </p:sp>
@@ -19897,7 +20417,7 @@
                 <a:ea typeface="Calibri" pitchFamily="34" charset="-122"/>
                 <a:cs typeface="Calibri" pitchFamily="34" charset="-120"/>
               </a:rPr>
-              <a:t xml:space="preserve">Cache son écran  </a:t>
+              <a:t>Cache son écran  </a:t>
             </a:r>
             <a:r>
               <a:rPr lang="en-US" sz="980" dirty="0">
@@ -19950,7 +20470,7 @@
                 <a:ea typeface="Calibri" pitchFamily="34" charset="-122"/>
                 <a:cs typeface="Calibri" pitchFamily="34" charset="-120"/>
               </a:rPr>
-              <a:t xml:space="preserve">S'isole / change d'humeur  </a:t>
+              <a:t>S'isole / change d'humeur  </a:t>
             </a:r>
             <a:r>
               <a:rPr lang="en-US" sz="980" dirty="0">
@@ -20003,7 +20523,7 @@
                 <a:ea typeface="Calibri" pitchFamily="34" charset="-122"/>
                 <a:cs typeface="Calibri" pitchFamily="34" charset="-120"/>
               </a:rPr>
-              <a:t xml:space="preserve">Inconnu insistant  </a:t>
+              <a:t>Inconnu insistant  </a:t>
             </a:r>
             <a:r>
               <a:rPr lang="en-US" sz="980" dirty="0">
@@ -20056,7 +20576,7 @@
                 <a:ea typeface="Calibri" pitchFamily="34" charset="-122"/>
                 <a:cs typeface="Calibri" pitchFamily="34" charset="-120"/>
               </a:rPr>
-              <a:t xml:space="preserve">Usage nocturne caché  </a:t>
+              <a:t>Usage nocturne caché  </a:t>
             </a:r>
             <a:r>
               <a:rPr lang="en-US" sz="980" dirty="0">
@@ -20109,7 +20629,7 @@
                 <a:ea typeface="Calibri" pitchFamily="34" charset="-122"/>
                 <a:cs typeface="Calibri" pitchFamily="34" charset="-120"/>
               </a:rPr>
-              <a:t xml:space="preserve">Demande de photo  </a:t>
+              <a:t>Demande de photo  </a:t>
             </a:r>
             <a:r>
               <a:rPr lang="en-US" sz="980" dirty="0">
@@ -20255,7 +20775,7 @@
                 <a:ea typeface="Calibri" pitchFamily="34" charset="-122"/>
                 <a:cs typeface="Calibri" pitchFamily="34" charset="-120"/>
               </a:rPr>
-              <a:t xml:space="preserve">Écrans dans le salon  </a:t>
+              <a:t>Écrans dans le salon  </a:t>
             </a:r>
             <a:r>
               <a:rPr lang="en-US" sz="980" dirty="0">
@@ -20308,7 +20828,7 @@
                 <a:ea typeface="Calibri" pitchFamily="34" charset="-122"/>
                 <a:cs typeface="Calibri" pitchFamily="34" charset="-120"/>
               </a:rPr>
-              <a:t xml:space="preserve">Contrôle parental  </a:t>
+              <a:t>Contrôle parental  </a:t>
             </a:r>
             <a:r>
               <a:rPr lang="en-US" sz="980" dirty="0">
@@ -20361,7 +20881,7 @@
                 <a:ea typeface="Calibri" pitchFamily="34" charset="-122"/>
                 <a:cs typeface="Calibri" pitchFamily="34" charset="-120"/>
               </a:rPr>
-              <a:t xml:space="preserve">Charte familiale  </a:t>
+              <a:t>Charte familiale  </a:t>
             </a:r>
             <a:r>
               <a:rPr lang="en-US" sz="980" dirty="0">
@@ -20414,7 +20934,7 @@
                 <a:ea typeface="Calibri" pitchFamily="34" charset="-122"/>
                 <a:cs typeface="Calibri" pitchFamily="34" charset="-120"/>
               </a:rPr>
-              <a:t xml:space="preserve">Dialogue ouvert  </a:t>
+              <a:t>Dialogue ouvert  </a:t>
             </a:r>
             <a:r>
               <a:rPr lang="en-US" sz="980" dirty="0">
@@ -20467,7 +20987,7 @@
                 <a:ea typeface="Calibri" pitchFamily="34" charset="-122"/>
                 <a:cs typeface="Calibri" pitchFamily="34" charset="-120"/>
               </a:rPr>
-              <a:t xml:space="preserve">Conserver les preuves  </a:t>
+              <a:t>Conserver les preuves  </a:t>
             </a:r>
             <a:r>
               <a:rPr lang="en-US" sz="980" dirty="0">
@@ -20613,7 +21133,7 @@
                 <a:ea typeface="Calibri" pitchFamily="34" charset="-122"/>
                 <a:cs typeface="Calibri" pitchFamily="34" charset="-120"/>
               </a:rPr>
-              <a:t xml:space="preserve">Cyberharcèlement  </a:t>
+              <a:t>Cyberharcèlement  </a:t>
             </a:r>
             <a:r>
               <a:rPr lang="en-US" sz="980" dirty="0">
@@ -20666,7 +21186,7 @@
                 <a:ea typeface="Calibri" pitchFamily="34" charset="-122"/>
                 <a:cs typeface="Calibri" pitchFamily="34" charset="-120"/>
               </a:rPr>
-              <a:t xml:space="preserve">Contenu illégal  </a:t>
+              <a:t>Contenu illégal  </a:t>
             </a:r>
             <a:r>
               <a:rPr lang="en-US" sz="980" dirty="0">
@@ -20719,7 +21239,7 @@
                 <a:ea typeface="Calibri" pitchFamily="34" charset="-122"/>
                 <a:cs typeface="Calibri" pitchFamily="34" charset="-120"/>
               </a:rPr>
-              <a:t xml:space="preserve">Aide &amp; conseils  </a:t>
+              <a:t>Aide &amp; conseils  </a:t>
             </a:r>
             <a:r>
               <a:rPr lang="en-US" sz="980" dirty="0">
@@ -20772,7 +21292,7 @@
                 <a:ea typeface="Calibri" pitchFamily="34" charset="-122"/>
                 <a:cs typeface="Calibri" pitchFamily="34" charset="-120"/>
               </a:rPr>
-              <a:t xml:space="preserve">Enfance en danger  </a:t>
+              <a:t>Enfance en danger  </a:t>
             </a:r>
             <a:r>
               <a:rPr lang="en-US" sz="980" dirty="0">
@@ -20825,7 +21345,7 @@
                 <a:ea typeface="Calibri" pitchFamily="34" charset="-122"/>
                 <a:cs typeface="Calibri" pitchFamily="34" charset="-120"/>
               </a:rPr>
-              <a:t xml:space="preserve">Toujours  </a:t>
+              <a:t>Toujours  </a:t>
             </a:r>
             <a:r>
               <a:rPr lang="en-US" sz="980" dirty="0">
@@ -20986,7 +21506,7 @@
                   </a:extLst>
                 </a:hlinkClick>
               </a:rPr>
-              <a:t xml:space="preserve">◀ </a:t>
+              <a:t>◀ </a:t>
             </a:r>
             <a:r>
               <a:rPr lang="en-US" sz="900" u="sng" dirty="0">
@@ -21106,7 +21626,7 @@
                   </a:extLst>
                 </a:hlinkClick>
               </a:rPr>
-              <a:t xml:space="preserve"> ▶</a:t>
+              <a:t> ▶</a:t>
             </a:r>
             <a:endParaRPr lang="en-US" sz="900" dirty="0"/>
           </a:p>
@@ -21193,6 +21713,46 @@
               <a:t>☰ Menu</a:t>
             </a:r>
             <a:endParaRPr lang="en-US" sz="750" dirty="0"/>
+          </a:p>
+        </p:txBody>
+      </p:sp>
+      <p:sp>
+        <p:nvSpPr>
+          <p:cNvPr id="37" name="ZoneTexte 36">
+            <a:extLst>
+              <a:ext uri="{FF2B5EF4-FFF2-40B4-BE49-F238E27FC236}">
+                <a16:creationId xmlns:a16="http://schemas.microsoft.com/office/drawing/2014/main" id="{F69B4D29-30A4-D071-B55B-B4F215D55E59}"/>
+              </a:ext>
+            </a:extLst>
+          </p:cNvPr>
+          <p:cNvSpPr txBox="1"/>
+          <p:nvPr/>
+        </p:nvSpPr>
+        <p:spPr>
+          <a:xfrm>
+            <a:off x="0" y="4864100"/>
+            <a:ext cx="9144000" cy="230832"/>
+          </a:xfrm>
+          <a:prstGeom prst="rect">
+            <a:avLst/>
+          </a:prstGeom>
+          <a:noFill/>
+        </p:spPr>
+        <p:txBody>
+          <a:bodyPr vert="horz" rtlCol="0">
+            <a:spAutoFit/>
+          </a:bodyPr>
+          <a:lstStyle/>
+          <a:p>
+            <a:pPr algn="ctr"/>
+            <a:r>
+              <a:rPr lang="fr-FR" sz="900">
+                <a:solidFill>
+                  <a:srgbClr val="B4B4B4"/>
+                </a:solidFill>
+              </a:rPr>
+              <a:t>(c) titi_23 - mediateur-numerique.github.io - Reproduction interdite sans autorisation</a:t>
+            </a:r>
           </a:p>
         </p:txBody>
       </p:sp>
@@ -21742,6 +22302,46 @@
           </a:p>
         </p:txBody>
       </p:sp>
+      <p:sp>
+        <p:nvSpPr>
+          <p:cNvPr id="15" name="ZoneTexte 14">
+            <a:extLst>
+              <a:ext uri="{FF2B5EF4-FFF2-40B4-BE49-F238E27FC236}">
+                <a16:creationId xmlns:a16="http://schemas.microsoft.com/office/drawing/2014/main" id="{1845A4AF-8EE9-3C2B-ADBA-91EF631473C7}"/>
+              </a:ext>
+            </a:extLst>
+          </p:cNvPr>
+          <p:cNvSpPr txBox="1"/>
+          <p:nvPr/>
+        </p:nvSpPr>
+        <p:spPr>
+          <a:xfrm>
+            <a:off x="0" y="4864100"/>
+            <a:ext cx="9144000" cy="230832"/>
+          </a:xfrm>
+          <a:prstGeom prst="rect">
+            <a:avLst/>
+          </a:prstGeom>
+          <a:noFill/>
+        </p:spPr>
+        <p:txBody>
+          <a:bodyPr vert="horz" rtlCol="0">
+            <a:spAutoFit/>
+          </a:bodyPr>
+          <a:lstStyle/>
+          <a:p>
+            <a:pPr algn="ctr"/>
+            <a:r>
+              <a:rPr lang="fr-FR" sz="900">
+                <a:solidFill>
+                  <a:srgbClr val="B4B4B4"/>
+                </a:solidFill>
+              </a:rPr>
+              <a:t>(c) titi_23 - mediateur-numerique.github.io - Reproduction interdite sans autorisation</a:t>
+            </a:r>
+          </a:p>
+        </p:txBody>
+      </p:sp>
     </p:spTree>
   </p:cSld>
   <p:clrMapOvr>
@@ -24388,7 +24988,7 @@
                   </a:extLst>
                 </a:hlinkClick>
               </a:rPr>
-              <a:t xml:space="preserve">◀ </a:t>
+              <a:t>◀ </a:t>
             </a:r>
             <a:r>
               <a:rPr lang="en-US" sz="900" u="sng" dirty="0">
@@ -24508,7 +25108,7 @@
                   </a:extLst>
                 </a:hlinkClick>
               </a:rPr>
-              <a:t xml:space="preserve"> ▶</a:t>
+              <a:t> ▶</a:t>
             </a:r>
             <a:endParaRPr lang="en-US" sz="900" dirty="0"/>
           </a:p>
@@ -24595,6 +25195,46 @@
               <a:t>☰ Menu</a:t>
             </a:r>
             <a:endParaRPr lang="en-US" sz="750" dirty="0"/>
+          </a:p>
+        </p:txBody>
+      </p:sp>
+      <p:sp>
+        <p:nvSpPr>
+          <p:cNvPr id="74" name="ZoneTexte 73">
+            <a:extLst>
+              <a:ext uri="{FF2B5EF4-FFF2-40B4-BE49-F238E27FC236}">
+                <a16:creationId xmlns:a16="http://schemas.microsoft.com/office/drawing/2014/main" id="{33BDCE67-B4A7-8F25-3D1B-84AD4380F419}"/>
+              </a:ext>
+            </a:extLst>
+          </p:cNvPr>
+          <p:cNvSpPr txBox="1"/>
+          <p:nvPr/>
+        </p:nvSpPr>
+        <p:spPr>
+          <a:xfrm>
+            <a:off x="0" y="4864100"/>
+            <a:ext cx="9144000" cy="230832"/>
+          </a:xfrm>
+          <a:prstGeom prst="rect">
+            <a:avLst/>
+          </a:prstGeom>
+          <a:noFill/>
+        </p:spPr>
+        <p:txBody>
+          <a:bodyPr vert="horz" rtlCol="0">
+            <a:spAutoFit/>
+          </a:bodyPr>
+          <a:lstStyle/>
+          <a:p>
+            <a:pPr algn="ctr"/>
+            <a:r>
+              <a:rPr lang="fr-FR" sz="900">
+                <a:solidFill>
+                  <a:srgbClr val="B4B4B4"/>
+                </a:solidFill>
+              </a:rPr>
+              <a:t>(c) titi_23 - mediateur-numerique.github.io - Reproduction interdite sans autorisation</a:t>
+            </a:r>
           </a:p>
         </p:txBody>
       </p:sp>
@@ -25615,7 +26255,7 @@
                   </a:extLst>
                 </a:hlinkClick>
               </a:rPr>
-              <a:t xml:space="preserve">◀ </a:t>
+              <a:t>◀ </a:t>
             </a:r>
             <a:r>
               <a:rPr lang="en-US" sz="900" u="sng" dirty="0">
@@ -25735,7 +26375,7 @@
                   </a:extLst>
                 </a:hlinkClick>
               </a:rPr>
-              <a:t xml:space="preserve"> ▶</a:t>
+              <a:t> ▶</a:t>
             </a:r>
             <a:endParaRPr lang="en-US" sz="900" dirty="0"/>
           </a:p>
@@ -25822,6 +26462,46 @@
               <a:t>☰ Menu</a:t>
             </a:r>
             <a:endParaRPr lang="en-US" sz="750" dirty="0"/>
+          </a:p>
+        </p:txBody>
+      </p:sp>
+      <p:sp>
+        <p:nvSpPr>
+          <p:cNvPr id="35" name="ZoneTexte 34">
+            <a:extLst>
+              <a:ext uri="{FF2B5EF4-FFF2-40B4-BE49-F238E27FC236}">
+                <a16:creationId xmlns:a16="http://schemas.microsoft.com/office/drawing/2014/main" id="{4B5CCCB2-6BC0-997B-21FF-D0D6D5909CE0}"/>
+              </a:ext>
+            </a:extLst>
+          </p:cNvPr>
+          <p:cNvSpPr txBox="1"/>
+          <p:nvPr/>
+        </p:nvSpPr>
+        <p:spPr>
+          <a:xfrm>
+            <a:off x="0" y="4864100"/>
+            <a:ext cx="9144000" cy="230832"/>
+          </a:xfrm>
+          <a:prstGeom prst="rect">
+            <a:avLst/>
+          </a:prstGeom>
+          <a:noFill/>
+        </p:spPr>
+        <p:txBody>
+          <a:bodyPr vert="horz" rtlCol="0">
+            <a:spAutoFit/>
+          </a:bodyPr>
+          <a:lstStyle/>
+          <a:p>
+            <a:pPr algn="ctr"/>
+            <a:r>
+              <a:rPr lang="fr-FR" sz="900">
+                <a:solidFill>
+                  <a:srgbClr val="B4B4B4"/>
+                </a:solidFill>
+              </a:rPr>
+              <a:t>(c) titi_23 - mediateur-numerique.github.io - Reproduction interdite sans autorisation</a:t>
+            </a:r>
           </a:p>
         </p:txBody>
       </p:sp>
@@ -27157,7 +27837,7 @@
                   </a:extLst>
                 </a:hlinkClick>
               </a:rPr>
-              <a:t xml:space="preserve">◀ </a:t>
+              <a:t>◀ </a:t>
             </a:r>
             <a:r>
               <a:rPr lang="en-US" sz="900" u="sng" dirty="0">
@@ -27277,7 +27957,7 @@
                   </a:extLst>
                 </a:hlinkClick>
               </a:rPr>
-              <a:t xml:space="preserve"> ▶</a:t>
+              <a:t> ▶</a:t>
             </a:r>
             <a:endParaRPr lang="en-US" sz="900" dirty="0"/>
           </a:p>
@@ -27364,6 +28044,46 @@
               <a:t>☰ Menu</a:t>
             </a:r>
             <a:endParaRPr lang="en-US" sz="750" dirty="0"/>
+          </a:p>
+        </p:txBody>
+      </p:sp>
+      <p:sp>
+        <p:nvSpPr>
+          <p:cNvPr id="44" name="ZoneTexte 43">
+            <a:extLst>
+              <a:ext uri="{FF2B5EF4-FFF2-40B4-BE49-F238E27FC236}">
+                <a16:creationId xmlns:a16="http://schemas.microsoft.com/office/drawing/2014/main" id="{57AF3F0E-C597-FB6B-DFE1-D4607E896338}"/>
+              </a:ext>
+            </a:extLst>
+          </p:cNvPr>
+          <p:cNvSpPr txBox="1"/>
+          <p:nvPr/>
+        </p:nvSpPr>
+        <p:spPr>
+          <a:xfrm>
+            <a:off x="0" y="4864100"/>
+            <a:ext cx="9144000" cy="230832"/>
+          </a:xfrm>
+          <a:prstGeom prst="rect">
+            <a:avLst/>
+          </a:prstGeom>
+          <a:noFill/>
+        </p:spPr>
+        <p:txBody>
+          <a:bodyPr vert="horz" rtlCol="0">
+            <a:spAutoFit/>
+          </a:bodyPr>
+          <a:lstStyle/>
+          <a:p>
+            <a:pPr algn="ctr"/>
+            <a:r>
+              <a:rPr lang="fr-FR" sz="900">
+                <a:solidFill>
+                  <a:srgbClr val="B4B4B4"/>
+                </a:solidFill>
+              </a:rPr>
+              <a:t>(c) titi_23 - mediateur-numerique.github.io - Reproduction interdite sans autorisation</a:t>
+            </a:r>
           </a:p>
         </p:txBody>
       </p:sp>
@@ -28300,7 +29020,7 @@
                 <a:ea typeface="Calibri" pitchFamily="34" charset="-122"/>
                 <a:cs typeface="Calibri" pitchFamily="34" charset="-120"/>
               </a:rPr>
-              <a:t xml:space="preserve">⚠  Le point commun : </a:t>
+              <a:t>⚠  Le point commun : </a:t>
             </a:r>
             <a:r>
               <a:rPr lang="en-US" sz="1200" dirty="0">
@@ -28461,7 +29181,7 @@
                   </a:extLst>
                 </a:hlinkClick>
               </a:rPr>
-              <a:t xml:space="preserve">◀ </a:t>
+              <a:t>◀ </a:t>
             </a:r>
             <a:r>
               <a:rPr lang="en-US" sz="900" u="sng" dirty="0">
@@ -28581,7 +29301,7 @@
                   </a:extLst>
                 </a:hlinkClick>
               </a:rPr>
-              <a:t xml:space="preserve"> ▶</a:t>
+              <a:t> ▶</a:t>
             </a:r>
             <a:endParaRPr lang="en-US" sz="900" dirty="0"/>
           </a:p>
@@ -28668,6 +29388,46 @@
               <a:t>☰ Menu</a:t>
             </a:r>
             <a:endParaRPr lang="en-US" sz="750" dirty="0"/>
+          </a:p>
+        </p:txBody>
+      </p:sp>
+      <p:sp>
+        <p:nvSpPr>
+          <p:cNvPr id="37" name="ZoneTexte 36">
+            <a:extLst>
+              <a:ext uri="{FF2B5EF4-FFF2-40B4-BE49-F238E27FC236}">
+                <a16:creationId xmlns:a16="http://schemas.microsoft.com/office/drawing/2014/main" id="{3AE48AD2-7617-8845-9EEA-D028D8780C89}"/>
+              </a:ext>
+            </a:extLst>
+          </p:cNvPr>
+          <p:cNvSpPr txBox="1"/>
+          <p:nvPr/>
+        </p:nvSpPr>
+        <p:spPr>
+          <a:xfrm>
+            <a:off x="0" y="4864100"/>
+            <a:ext cx="9144000" cy="230832"/>
+          </a:xfrm>
+          <a:prstGeom prst="rect">
+            <a:avLst/>
+          </a:prstGeom>
+          <a:noFill/>
+        </p:spPr>
+        <p:txBody>
+          <a:bodyPr vert="horz" rtlCol="0">
+            <a:spAutoFit/>
+          </a:bodyPr>
+          <a:lstStyle/>
+          <a:p>
+            <a:pPr algn="ctr"/>
+            <a:r>
+              <a:rPr lang="fr-FR" sz="900">
+                <a:solidFill>
+                  <a:srgbClr val="B4B4B4"/>
+                </a:solidFill>
+              </a:rPr>
+              <a:t>(c) titi_23 - mediateur-numerique.github.io - Reproduction interdite sans autorisation</a:t>
+            </a:r>
           </a:p>
         </p:txBody>
       </p:sp>
@@ -29637,7 +30397,7 @@
                 <a:ea typeface="Calibri" pitchFamily="34" charset="-122"/>
                 <a:cs typeface="Calibri" pitchFamily="34" charset="-120"/>
               </a:rPr>
-              <a:t xml:space="preserve">Règle d'or : </a:t>
+              <a:t>Règle d'or : </a:t>
             </a:r>
             <a:r>
               <a:rPr lang="en-US" sz="1200" dirty="0">
@@ -29798,7 +30558,7 @@
                   </a:extLst>
                 </a:hlinkClick>
               </a:rPr>
-              <a:t xml:space="preserve">◀ </a:t>
+              <a:t>◀ </a:t>
             </a:r>
             <a:r>
               <a:rPr lang="en-US" sz="900" u="sng" dirty="0">
@@ -29918,7 +30678,7 @@
                   </a:extLst>
                 </a:hlinkClick>
               </a:rPr>
-              <a:t xml:space="preserve"> ▶</a:t>
+              <a:t> ▶</a:t>
             </a:r>
             <a:endParaRPr lang="en-US" sz="900" dirty="0"/>
           </a:p>
@@ -30005,6 +30765,46 @@
               <a:t>☰ Menu</a:t>
             </a:r>
             <a:endParaRPr lang="en-US" sz="750" dirty="0"/>
+          </a:p>
+        </p:txBody>
+      </p:sp>
+      <p:sp>
+        <p:nvSpPr>
+          <p:cNvPr id="33" name="ZoneTexte 32">
+            <a:extLst>
+              <a:ext uri="{FF2B5EF4-FFF2-40B4-BE49-F238E27FC236}">
+                <a16:creationId xmlns:a16="http://schemas.microsoft.com/office/drawing/2014/main" id="{ADD3E85C-7D63-D255-1635-040AC63074FC}"/>
+              </a:ext>
+            </a:extLst>
+          </p:cNvPr>
+          <p:cNvSpPr txBox="1"/>
+          <p:nvPr/>
+        </p:nvSpPr>
+        <p:spPr>
+          <a:xfrm>
+            <a:off x="0" y="4864100"/>
+            <a:ext cx="9144000" cy="230832"/>
+          </a:xfrm>
+          <a:prstGeom prst="rect">
+            <a:avLst/>
+          </a:prstGeom>
+          <a:noFill/>
+        </p:spPr>
+        <p:txBody>
+          <a:bodyPr vert="horz" rtlCol="0">
+            <a:spAutoFit/>
+          </a:bodyPr>
+          <a:lstStyle/>
+          <a:p>
+            <a:pPr algn="ctr"/>
+            <a:r>
+              <a:rPr lang="fr-FR" sz="900">
+                <a:solidFill>
+                  <a:srgbClr val="B4B4B4"/>
+                </a:solidFill>
+              </a:rPr>
+              <a:t>(c) titi_23 - mediateur-numerique.github.io - Reproduction interdite sans autorisation</a:t>
+            </a:r>
           </a:p>
         </p:txBody>
       </p:sp>
@@ -31045,7 +31845,7 @@
                   </a:extLst>
                 </a:hlinkClick>
               </a:rPr>
-              <a:t xml:space="preserve">◀ </a:t>
+              <a:t>◀ </a:t>
             </a:r>
             <a:r>
               <a:rPr lang="en-US" sz="900" u="sng" dirty="0">
@@ -31165,7 +31965,7 @@
                   </a:extLst>
                 </a:hlinkClick>
               </a:rPr>
-              <a:t xml:space="preserve"> ▶</a:t>
+              <a:t> ▶</a:t>
             </a:r>
             <a:endParaRPr lang="en-US" sz="900" dirty="0"/>
           </a:p>
@@ -31252,6 +32052,46 @@
               <a:t>☰ Menu</a:t>
             </a:r>
             <a:endParaRPr lang="en-US" sz="750" dirty="0"/>
+          </a:p>
+        </p:txBody>
+      </p:sp>
+      <p:sp>
+        <p:nvSpPr>
+          <p:cNvPr id="35" name="ZoneTexte 34">
+            <a:extLst>
+              <a:ext uri="{FF2B5EF4-FFF2-40B4-BE49-F238E27FC236}">
+                <a16:creationId xmlns:a16="http://schemas.microsoft.com/office/drawing/2014/main" id="{7792F425-6320-76E4-C8B3-BBAE4225535E}"/>
+              </a:ext>
+            </a:extLst>
+          </p:cNvPr>
+          <p:cNvSpPr txBox="1"/>
+          <p:nvPr/>
+        </p:nvSpPr>
+        <p:spPr>
+          <a:xfrm>
+            <a:off x="0" y="4864100"/>
+            <a:ext cx="9144000" cy="230832"/>
+          </a:xfrm>
+          <a:prstGeom prst="rect">
+            <a:avLst/>
+          </a:prstGeom>
+          <a:noFill/>
+        </p:spPr>
+        <p:txBody>
+          <a:bodyPr vert="horz" rtlCol="0">
+            <a:spAutoFit/>
+          </a:bodyPr>
+          <a:lstStyle/>
+          <a:p>
+            <a:pPr algn="ctr"/>
+            <a:r>
+              <a:rPr lang="fr-FR" sz="900">
+                <a:solidFill>
+                  <a:srgbClr val="B4B4B4"/>
+                </a:solidFill>
+              </a:rPr>
+              <a:t>(c) titi_23 - mediateur-numerique.github.io - Reproduction interdite sans autorisation</a:t>
+            </a:r>
           </a:p>
         </p:txBody>
       </p:sp>
@@ -32321,7 +33161,7 @@
                   </a:extLst>
                 </a:hlinkClick>
               </a:rPr>
-              <a:t xml:space="preserve">◀ </a:t>
+              <a:t>◀ </a:t>
             </a:r>
             <a:r>
               <a:rPr lang="en-US" sz="900" u="sng" dirty="0">
@@ -32441,7 +33281,7 @@
                   </a:extLst>
                 </a:hlinkClick>
               </a:rPr>
-              <a:t xml:space="preserve"> ▶</a:t>
+              <a:t> ▶</a:t>
             </a:r>
             <a:endParaRPr lang="en-US" sz="900" dirty="0"/>
           </a:p>
@@ -32528,6 +33368,46 @@
               <a:t>☰ Menu</a:t>
             </a:r>
             <a:endParaRPr lang="en-US" sz="750" dirty="0"/>
+          </a:p>
+        </p:txBody>
+      </p:sp>
+      <p:sp>
+        <p:nvSpPr>
+          <p:cNvPr id="35" name="ZoneTexte 34">
+            <a:extLst>
+              <a:ext uri="{FF2B5EF4-FFF2-40B4-BE49-F238E27FC236}">
+                <a16:creationId xmlns:a16="http://schemas.microsoft.com/office/drawing/2014/main" id="{9697B487-A53D-E02B-DFCB-DF256D9DF99C}"/>
+              </a:ext>
+            </a:extLst>
+          </p:cNvPr>
+          <p:cNvSpPr txBox="1"/>
+          <p:nvPr/>
+        </p:nvSpPr>
+        <p:spPr>
+          <a:xfrm>
+            <a:off x="0" y="4864100"/>
+            <a:ext cx="9144000" cy="230832"/>
+          </a:xfrm>
+          <a:prstGeom prst="rect">
+            <a:avLst/>
+          </a:prstGeom>
+          <a:noFill/>
+        </p:spPr>
+        <p:txBody>
+          <a:bodyPr vert="horz" rtlCol="0">
+            <a:spAutoFit/>
+          </a:bodyPr>
+          <a:lstStyle/>
+          <a:p>
+            <a:pPr algn="ctr"/>
+            <a:r>
+              <a:rPr lang="fr-FR" sz="900">
+                <a:solidFill>
+                  <a:srgbClr val="B4B4B4"/>
+                </a:solidFill>
+              </a:rPr>
+              <a:t>(c) titi_23 - mediateur-numerique.github.io - Reproduction interdite sans autorisation</a:t>
+            </a:r>
           </a:p>
         </p:txBody>
       </p:sp>

</xml_diff>